<commit_message>
feat(build_slides): minutes per chapter; CNS sections 120 min, paired chapters 60 min
Co-Authored-By: Claude Opus 5.5 <noreply@anthropic.com>
</commit_message>
<xml_diff>
--- a/projects/cns-pharmacology-practical/slides/ch02-psychosis.pptx
+++ b/projects/cns-pharmacology-practical/slides/ch02-psychosis.pptx
@@ -7736,7 +7736,7 @@
                 </a:solidFill>
                 <a:latin typeface="Calibri"/>
               </a:rPr>
-              <a:t>45 minutes  ·  10 questions</a:t>
+              <a:t>60 minutes  ·  10 questions</a:t>
             </a:r>
           </a:p>
         </p:txBody>
@@ -14330,7 +14330,7 @@
                 </a:solidFill>
                 <a:latin typeface="Cambria"/>
               </a:rPr>
-              <a:t>45</a:t>
+              <a:t>60</a:t>
             </a:r>
           </a:p>
           <a:p>

</xml_diff>